<commit_message>
Update results and slides with PubMed, Wisconsin, Cornell experiments
- New sweep results: PubMed injection + Texas/Wisconsin/Cornell heterophily
- contribution_results.png: expanded to 4 panels covering all 5 datasets
- trust_gate_deck.pptx: slides 6-7 updated with new multi-dataset results
- Pattern confirmed: Gate B/C robust on injection, cosine gates hurt on heterophily

Co-Authored-By: Claude Sonnet 4.6 <noreply@anthropic.com>
</commit_message>
<xml_diff>
--- a/slides/trust_gate_deck.pptx
+++ b/slides/trust_gate_deck.pptx
@@ -7390,7 +7390,7 @@
                   <a:srgbClr val="FFFFFF"/>
                 </a:solidFill>
               </a:rPr>
-              <a:t>Result 1 — Injection Robustness on Cora</a:t>
+              <a:t>Result 1 — Injection Robustness (Cora + PubMed)</a:t>
             </a:r>
           </a:p>
         </p:txBody>
@@ -7424,7 +7424,7 @@
                   <a:srgbClr val="D6BCFA"/>
                 </a:solidFill>
               </a:rPr>
-              <a:t>B (confidence) degrades least: only −3.6 pp at 50% injection</a:t>
+              <a:t>Gate B most robust on both datasets: −3.6 pp (Cora), −2.6 pp (PubMed)</a:t>
             </a:r>
           </a:p>
         </p:txBody>
@@ -7446,7 +7446,7 @@
         <p:spPr>
           <a:xfrm>
             <a:off x="274320" y="1143000"/>
-            <a:ext cx="8046720" cy="3969153"/>
+            <a:ext cx="8686800" cy="4035847"/>
           </a:xfrm>
           <a:prstGeom prst="rect">
             <a:avLst/>
@@ -7461,8 +7461,8 @@
         </p:nvSpPr>
         <p:spPr>
           <a:xfrm>
-            <a:off x="8503920" y="1143000"/>
-            <a:ext cx="3474720" cy="5394960"/>
+            <a:off x="9098280" y="1143000"/>
+            <a:ext cx="2880360" cy="5394960"/>
           </a:xfrm>
           <a:prstGeom prst="rect">
             <a:avLst/>
@@ -7506,8 +7506,8 @@
         </p:nvSpPr>
         <p:spPr>
           <a:xfrm>
-            <a:off x="8595360" y="1234440"/>
-            <a:ext cx="3291840" cy="457200"/>
+            <a:off x="9189720" y="1234440"/>
+            <a:ext cx="2697480" cy="457200"/>
           </a:xfrm>
           <a:prstGeom prst="rect">
             <a:avLst/>
@@ -7540,8 +7540,8 @@
         </p:nvSpPr>
         <p:spPr>
           <a:xfrm>
-            <a:off x="8595360" y="1783080"/>
-            <a:ext cx="3291840" cy="914400"/>
+            <a:off x="9189720" y="1783080"/>
+            <a:ext cx="2697480" cy="914400"/>
           </a:xfrm>
           <a:prstGeom prst="rect">
             <a:avLst/>
@@ -7556,12 +7556,12 @@
           <a:p>
             <a:pPr algn="l"/>
             <a:r>
-              <a:rPr sz="1150" b="0" i="0">
+              <a:rPr sz="1100" b="0" i="0">
                 <a:solidFill>
                   <a:srgbClr val="1A202C"/>
                 </a:solidFill>
               </a:rPr>
-              <a:t>• Gate B (confidence) most robust: −3.6 pp</a:t>
+              <a:t>• B (confidence) most robust on both Cora (−3.6) and PubMed (−2.6 pp)</a:t>
             </a:r>
           </a:p>
         </p:txBody>
@@ -7574,8 +7574,8 @@
         </p:nvSpPr>
         <p:spPr>
           <a:xfrm>
-            <a:off x="8595360" y="2788920"/>
-            <a:ext cx="3291840" cy="914400"/>
+            <a:off x="9189720" y="2788920"/>
+            <a:ext cx="2697480" cy="914400"/>
           </a:xfrm>
           <a:prstGeom prst="rect">
             <a:avLst/>
@@ -7590,12 +7590,12 @@
           <a:p>
             <a:pPr algn="l"/>
             <a:r>
-              <a:rPr sz="1150" b="0" i="0">
+              <a:rPr sz="1100" b="0" i="0">
                 <a:solidFill>
                   <a:srgbClr val="1A202C"/>
                 </a:solidFill>
               </a:rPr>
-              <a:t>• Cosine gates (A, D) track baseline — offer no extra robustness</a:t>
+              <a:t>• C (learned MLP) also stable: −5.9 pp Cora, −1.1 pp PubMed</a:t>
             </a:r>
           </a:p>
         </p:txBody>
@@ -7608,8 +7608,8 @@
         </p:nvSpPr>
         <p:spPr>
           <a:xfrm>
-            <a:off x="8595360" y="3794760"/>
-            <a:ext cx="3291840" cy="914400"/>
+            <a:off x="9189720" y="3794760"/>
+            <a:ext cx="2697480" cy="914400"/>
           </a:xfrm>
           <a:prstGeom prst="rect">
             <a:avLst/>
@@ -7624,12 +7624,12 @@
           <a:p>
             <a:pPr algn="l"/>
             <a:r>
-              <a:rPr sz="1150" b="0" i="0">
+              <a:rPr sz="1100" b="0" i="0">
                 <a:solidFill>
                   <a:srgbClr val="1A202C"/>
                 </a:solidFill>
               </a:rPr>
-              <a:t>• Gate C (learned) degrades faster than B</a:t>
+              <a:t>• Cosine gates (A, D): −8.4 pp — no robustness benefit</a:t>
             </a:r>
           </a:p>
         </p:txBody>
@@ -7642,8 +7642,8 @@
         </p:nvSpPr>
         <p:spPr>
           <a:xfrm>
-            <a:off x="8595360" y="4800600"/>
-            <a:ext cx="3291840" cy="914400"/>
+            <a:off x="9189720" y="4800600"/>
+            <a:ext cx="2697480" cy="914400"/>
           </a:xfrm>
           <a:prstGeom prst="rect">
             <a:avLst/>
@@ -7658,12 +7658,12 @@
           <a:p>
             <a:pPr algn="l"/>
             <a:r>
-              <a:rPr sz="1150" b="0" i="0">
+              <a:rPr sz="1100" b="0" i="0">
                 <a:solidFill>
                   <a:srgbClr val="1A202C"/>
                 </a:solidFill>
               </a:rPr>
-              <a:t>• All gates converge at 50% injection (≈71%)</a:t>
+              <a:t>• Pattern consistent across two independent datasets</a:t>
             </a:r>
           </a:p>
         </p:txBody>
@@ -7766,7 +7766,7 @@
                   <a:srgbClr val="FFFFFF"/>
                 </a:solidFill>
               </a:rPr>
-              <a:t>Result 2 — Heterophily Generalization on Texas</a:t>
+              <a:t>Result 2 — Heterophily Generalization (3 Datasets)</a:t>
             </a:r>
           </a:p>
         </p:txBody>
@@ -7800,7 +7800,7 @@
                   <a:srgbClr val="D6BCFA"/>
                 </a:solidFill>
               </a:rPr>
-              <a:t>Gates B &amp; C reach 81.1% — outperforming GraphSAGE by +4.5 pp</a:t>
+              <a:t>B &amp; C improve over baseline on ALL three datasets; cosine gates consistently hurt</a:t>
             </a:r>
           </a:p>
         </p:txBody>
@@ -7822,7 +7822,7 @@
         <p:spPr>
           <a:xfrm>
             <a:off x="274320" y="1143000"/>
-            <a:ext cx="8046720" cy="4252577"/>
+            <a:ext cx="8229600" cy="4358663"/>
           </a:xfrm>
           <a:prstGeom prst="rect">
             <a:avLst/>
@@ -7837,8 +7837,8 @@
         </p:nvSpPr>
         <p:spPr>
           <a:xfrm>
-            <a:off x="8503920" y="1143000"/>
-            <a:ext cx="3474720" cy="5394960"/>
+            <a:off x="8686800" y="1143000"/>
+            <a:ext cx="3291840" cy="5394960"/>
           </a:xfrm>
           <a:prstGeom prst="rect">
             <a:avLst/>
@@ -7882,8 +7882,8 @@
         </p:nvSpPr>
         <p:spPr>
           <a:xfrm>
-            <a:off x="8595360" y="1234440"/>
-            <a:ext cx="3291840" cy="457200"/>
+            <a:off x="8778240" y="1234440"/>
+            <a:ext cx="3108960" cy="457200"/>
           </a:xfrm>
           <a:prstGeom prst="rect">
             <a:avLst/>
@@ -7916,8 +7916,8 @@
         </p:nvSpPr>
         <p:spPr>
           <a:xfrm>
-            <a:off x="8595360" y="1783080"/>
-            <a:ext cx="3291840" cy="914400"/>
+            <a:off x="8778240" y="1783080"/>
+            <a:ext cx="3108960" cy="841248"/>
           </a:xfrm>
           <a:prstGeom prst="rect">
             <a:avLst/>
@@ -7932,12 +7932,12 @@
           <a:p>
             <a:pPr algn="l"/>
             <a:r>
-              <a:rPr sz="1150" b="0" i="0">
+              <a:rPr sz="1100" b="0" i="0">
                 <a:solidFill>
                   <a:srgbClr val="1A202C"/>
                 </a:solidFill>
               </a:rPr>
-              <a:t>• B &amp; C: 81.1% — best among our gates</a:t>
+              <a:t>• Texas:     B &amp; C → 81.1%  (+4.5 pp)</a:t>
             </a:r>
           </a:p>
         </p:txBody>
@@ -7950,8 +7950,8 @@
         </p:nvSpPr>
         <p:spPr>
           <a:xfrm>
-            <a:off x="8595360" y="2788920"/>
-            <a:ext cx="3291840" cy="914400"/>
+            <a:off x="8778240" y="2679191"/>
+            <a:ext cx="3108960" cy="841248"/>
           </a:xfrm>
           <a:prstGeom prst="rect">
             <a:avLst/>
@@ -7966,12 +7966,12 @@
           <a:p>
             <a:pPr algn="l"/>
             <a:r>
-              <a:rPr sz="1150" b="0" i="0">
+              <a:rPr sz="1100" b="0" i="0">
                 <a:solidFill>
                   <a:srgbClr val="1A202C"/>
                 </a:solidFill>
               </a:rPr>
-              <a:t>• A &amp; D (cosine) HURT vs. baseline: 58.6%, 60.4%</a:t>
+              <a:t>• Wisconsin: B &amp; C → 86.9%  (+5.9 pp)</a:t>
             </a:r>
           </a:p>
         </p:txBody>
@@ -7984,8 +7984,8 @@
         </p:nvSpPr>
         <p:spPr>
           <a:xfrm>
-            <a:off x="8595360" y="3794760"/>
-            <a:ext cx="3291840" cy="914400"/>
+            <a:off x="8778240" y="3575304"/>
+            <a:ext cx="3108960" cy="841248"/>
           </a:xfrm>
           <a:prstGeom prst="rect">
             <a:avLst/>
@@ -8000,12 +8000,12 @@
           <a:p>
             <a:pPr algn="l"/>
             <a:r>
-              <a:rPr sz="1150" b="0" i="0">
+              <a:rPr sz="1100" b="0" i="0">
                 <a:solidFill>
                   <a:srgbClr val="1A202C"/>
                 </a:solidFill>
               </a:rPr>
-              <a:t>• Cosine similarity ≠ class compatibility on heterophilic graphs</a:t>
+              <a:t>• Cornell:   B     → 76.6%  (+4.5 pp)</a:t>
             </a:r>
           </a:p>
         </p:txBody>
@@ -8018,8 +8018,8 @@
         </p:nvSpPr>
         <p:spPr>
           <a:xfrm>
-            <a:off x="8595360" y="4800600"/>
-            <a:ext cx="3291840" cy="914400"/>
+            <a:off x="8778240" y="4471416"/>
+            <a:ext cx="3108960" cy="841248"/>
           </a:xfrm>
           <a:prstGeom prst="rect">
             <a:avLst/>
@@ -8034,12 +8034,46 @@
           <a:p>
             <a:pPr algn="l"/>
             <a:r>
-              <a:rPr sz="1150" b="0" i="0">
+              <a:rPr sz="1100" b="0" i="0">
                 <a:solidFill>
                   <a:srgbClr val="1A202C"/>
                 </a:solidFill>
               </a:rPr>
-              <a:t>• Gap to GPR-GNN (92.9%) — specialist vs. general method</a:t>
+              <a:t>• Cosine gates (A, D) hurt on ALL three — drop 15–20 pp below baseline</a:t>
+            </a:r>
+          </a:p>
+        </p:txBody>
+      </p:sp>
+      <p:sp>
+        <p:nvSpPr>
+          <p:cNvPr id="12" name="TextBox 11"/>
+          <p:cNvSpPr txBox="1"/>
+          <p:nvPr/>
+        </p:nvSpPr>
+        <p:spPr>
+          <a:xfrm>
+            <a:off x="8778240" y="5367528"/>
+            <a:ext cx="3108960" cy="841248"/>
+          </a:xfrm>
+          <a:prstGeom prst="rect">
+            <a:avLst/>
+          </a:prstGeom>
+          <a:noFill/>
+        </p:spPr>
+        <p:txBody>
+          <a:bodyPr wrap="square">
+            <a:spAutoFit/>
+          </a:bodyPr>
+          <a:lstStyle/>
+          <a:p>
+            <a:pPr algn="l"/>
+            <a:r>
+              <a:rPr sz="1100" b="0" i="0">
+                <a:solidFill>
+                  <a:srgbClr val="1A202C"/>
+                </a:solidFill>
+              </a:rPr>
+              <a:t>• Confidence signal reliable regardless of graph structure</a:t>
             </a:r>
           </a:p>
         </p:txBody>
@@ -8198,7 +8232,7 @@
         <p:spPr>
           <a:xfrm>
             <a:off x="137160" y="1097280"/>
-            <a:ext cx="11887200" cy="3762462"/>
+            <a:ext cx="11887200" cy="2983757"/>
           </a:xfrm>
           <a:prstGeom prst="rect">
             <a:avLst/>

</xml_diff>